<commit_message>
Remove notebooks from gitignore template
</commit_message>
<xml_diff>
--- a/workshops/week02/git_slides.pptx
+++ b/workshops/week02/git_slides.pptx
@@ -9497,10 +9497,10 @@
           <a:ln/>
         </p:spPr>
         <p:txBody>
-          <a:bodyPr wrap="square" lIns="0" tIns="0" rIns="0" bIns="0" rtlCol="0" anchor="t"/>
-          <a:lstStyle/>
-          <a:p>
-            <a:pPr marL="0" indent="0" algn="ctr">
+          <a:bodyPr wrap="square" lIns="0" tIns="0" rIns="0" bIns="0" rtlCol="0" anchor="ctr"/>
+          <a:lstStyle/>
+          <a:p>
+            <a:pPr marL="0" indent="0" algn="r">
               <a:buNone/>
             </a:pPr>
             <a:r>
@@ -10141,7 +10141,7 @@
               <a:buNone/>
             </a:pPr>
             <a:r>
-              <a:rPr lang="en-US" sz="1350" b="1" dirty="0">
+              <a:rPr lang="en-US" sz="1350" b="1" i="1" dirty="0">
                 <a:solidFill>
                   <a:srgbClr val="1E2761"/>
                 </a:solidFill>
@@ -10152,7 +10152,7 @@
               <a:t>Use the email you'll use for GitHub</a:t>
             </a:r>
             <a:r>
-              <a:rPr lang="en-US" sz="1350" dirty="0">
+              <a:rPr lang="en-US" sz="1350" i="1" dirty="0">
                 <a:solidFill>
                   <a:srgbClr val="1E2761"/>
                 </a:solidFill>
@@ -12767,149 +12767,6 @@
                 <a:extLst>
                   <a:ext uri="{0D108BD9-81ED-4DB2-BD59-A6C34878D82A}">
                     <a16:rowId xmlns:a16="http://schemas.microsoft.com/office/drawing/2014/main" val="10000"/>
-                  </a:ext>
-                </a:extLst>
-              </a:tr>
-              <a:tr h="0">
-                <a:tc>
-                  <a:txBody>
-                    <a:bodyPr/>
-                    <a:lstStyle/>
-                    <a:p>
-                      <a:pPr marL="0" indent="0">
-                        <a:buNone/>
-                      </a:pPr>
-                      <a:r>
-                        <a:rPr lang="en-US" sz="1350" dirty="0">
-                          <a:solidFill>
-                            <a:srgbClr val="1E2761"/>
-                          </a:solidFill>
-                          <a:latin typeface="Calibri" pitchFamily="34" charset="0"/>
-                          <a:ea typeface="Calibri" pitchFamily="34" charset="-122"/>
-                          <a:cs typeface="Calibri" pitchFamily="34" charset="-120"/>
-                        </a:rPr>
-                        <a:t>*.ipynb</a:t>
-                      </a:r>
-                      <a:endParaRPr lang="en-US" sz="1350" dirty="0">
-                        <a:latin typeface="Calibri" charset="0"/>
-                        <a:ea typeface="Calibri" charset="0"/>
-                        <a:cs typeface="Calibri" charset="0"/>
-                      </a:endParaRPr>
-                    </a:p>
-                  </a:txBody>
-                  <a:tcPr marL="127000" marR="127000" marT="76200" marB="76200" anchor="ctr">
-                    <a:lnL w="9525" cap="flat" cmpd="sng" algn="ctr">
-                      <a:solidFill>
-                        <a:srgbClr val="D9DEE9"/>
-                      </a:solidFill>
-                      <a:prstDash val="solid"/>
-                      <a:round/>
-                      <a:headEnd type="none" w="med" len="med"/>
-                      <a:tailEnd type="none" w="med" len="med"/>
-                    </a:lnL>
-                    <a:lnR w="9525" cap="flat" cmpd="sng" algn="ctr">
-                      <a:solidFill>
-                        <a:srgbClr val="D9DEE9"/>
-                      </a:solidFill>
-                      <a:prstDash val="solid"/>
-                      <a:round/>
-                      <a:headEnd type="none" w="med" len="med"/>
-                      <a:tailEnd type="none" w="med" len="med"/>
-                    </a:lnR>
-                    <a:lnT w="9525" cap="flat" cmpd="sng" algn="ctr">
-                      <a:solidFill>
-                        <a:srgbClr val="D9DEE9"/>
-                      </a:solidFill>
-                      <a:prstDash val="solid"/>
-                      <a:round/>
-                      <a:headEnd type="none" w="med" len="med"/>
-                      <a:tailEnd type="none" w="med" len="med"/>
-                    </a:lnT>
-                    <a:lnB w="9525" cap="flat" cmpd="sng" algn="ctr">
-                      <a:solidFill>
-                        <a:srgbClr val="D9DEE9"/>
-                      </a:solidFill>
-                      <a:prstDash val="solid"/>
-                      <a:round/>
-                      <a:headEnd type="none" w="med" len="med"/>
-                      <a:tailEnd type="none" w="med" len="med"/>
-                    </a:lnB>
-                    <a:solidFill>
-                      <a:srgbClr val="FFFFFF"/>
-                    </a:solidFill>
-                  </a:tcPr>
-                </a:tc>
-                <a:tc>
-                  <a:txBody>
-                    <a:bodyPr/>
-                    <a:lstStyle/>
-                    <a:p>
-                      <a:pPr marL="0" indent="0">
-                        <a:buNone/>
-                      </a:pPr>
-                      <a:r>
-                        <a:rPr lang="en-US" sz="1350" dirty="0">
-                          <a:solidFill>
-                            <a:srgbClr val="1E2761"/>
-                          </a:solidFill>
-                          <a:latin typeface="Calibri" pitchFamily="34" charset="0"/>
-                          <a:ea typeface="Calibri" pitchFamily="34" charset="-122"/>
-                          <a:cs typeface="Calibri" pitchFamily="34" charset="-120"/>
-                        </a:rPr>
-                        <a:t>Notebooks are given material, not this week's exercise scripts</a:t>
-                      </a:r>
-                      <a:endParaRPr lang="en-US" sz="1350" dirty="0">
-                        <a:latin typeface="Calibri" charset="0"/>
-                        <a:ea typeface="Calibri" charset="0"/>
-                        <a:cs typeface="Calibri" charset="0"/>
-                      </a:endParaRPr>
-                    </a:p>
-                  </a:txBody>
-                  <a:tcPr marL="127000" marR="127000" marT="76200" marB="76200" anchor="ctr">
-                    <a:lnL w="9525" cap="flat" cmpd="sng" algn="ctr">
-                      <a:solidFill>
-                        <a:srgbClr val="D9DEE9"/>
-                      </a:solidFill>
-                      <a:prstDash val="solid"/>
-                      <a:round/>
-                      <a:headEnd type="none" w="med" len="med"/>
-                      <a:tailEnd type="none" w="med" len="med"/>
-                    </a:lnL>
-                    <a:lnR w="9525" cap="flat" cmpd="sng" algn="ctr">
-                      <a:solidFill>
-                        <a:srgbClr val="D9DEE9"/>
-                      </a:solidFill>
-                      <a:prstDash val="solid"/>
-                      <a:round/>
-                      <a:headEnd type="none" w="med" len="med"/>
-                      <a:tailEnd type="none" w="med" len="med"/>
-                    </a:lnR>
-                    <a:lnT w="9525" cap="flat" cmpd="sng" algn="ctr">
-                      <a:solidFill>
-                        <a:srgbClr val="D9DEE9"/>
-                      </a:solidFill>
-                      <a:prstDash val="solid"/>
-                      <a:round/>
-                      <a:headEnd type="none" w="med" len="med"/>
-                      <a:tailEnd type="none" w="med" len="med"/>
-                    </a:lnT>
-                    <a:lnB w="9525" cap="flat" cmpd="sng" algn="ctr">
-                      <a:solidFill>
-                        <a:srgbClr val="D9DEE9"/>
-                      </a:solidFill>
-                      <a:prstDash val="solid"/>
-                      <a:round/>
-                      <a:headEnd type="none" w="med" len="med"/>
-                      <a:tailEnd type="none" w="med" len="med"/>
-                    </a:lnB>
-                    <a:solidFill>
-                      <a:srgbClr val="FFFFFF"/>
-                    </a:solidFill>
-                  </a:tcPr>
-                </a:tc>
-                <a:extLst>
-                  <a:ext uri="{0D108BD9-81ED-4DB2-BD59-A6C34878D82A}">
-                    <a16:rowId xmlns:a16="http://schemas.microsoft.com/office/drawing/2014/main" val="10001"/>
                   </a:ext>
                 </a:extLst>
               </a:tr>

</xml_diff>